<commit_message>
Adding "Next Steps" to scripts Cleaning up
</commit_message>
<xml_diff>
--- a/MainDocs/Images.pptx
+++ b/MainDocs/Images.pptx
@@ -273,7 +273,7 @@
             <a:fld id="{5F993C83-2184-4286-ABE1-941A40B40C8F}" type="datetimeFigureOut">
               <a:rPr lang="en-US" smtClean="0"/>
               <a:pPr/>
-              <a:t>3/16/2026</a:t>
+              <a:t>4/2/2026</a:t>
             </a:fld>
             <a:endParaRPr lang="en-US"/>
           </a:p>
@@ -440,7 +440,7 @@
             <a:fld id="{6053241F-7ED4-45AC-844C-15DB0D5F9CCD}" type="datetimeFigureOut">
               <a:rPr lang="en-US" smtClean="0"/>
               <a:pPr/>
-              <a:t>3/16/2026</a:t>
+              <a:t>4/2/2026</a:t>
             </a:fld>
             <a:endParaRPr lang="en-US"/>
           </a:p>
@@ -3440,10 +3440,10 @@
       </p:grpSpPr>
       <p:grpSp>
         <p:nvGrpSpPr>
-          <p:cNvPr id="31" name="Group 30">
+          <p:cNvPr id="39" name="Group 38">
             <a:extLst>
               <a:ext uri="{FF2B5EF4-FFF2-40B4-BE49-F238E27FC236}">
-                <a16:creationId xmlns:a16="http://schemas.microsoft.com/office/drawing/2014/main" id="{20D5265E-874A-8DED-82FD-2AE029C01BB0}"/>
+                <a16:creationId xmlns:a16="http://schemas.microsoft.com/office/drawing/2014/main" id="{0054C296-233E-6374-7ACA-9F2C240D2FB1}"/>
               </a:ext>
             </a:extLst>
           </p:cNvPr>
@@ -3453,64 +3453,450 @@
         <p:grpSpPr>
           <a:xfrm>
             <a:off x="407368" y="980728"/>
-            <a:ext cx="6840760" cy="4489673"/>
+            <a:ext cx="9263183" cy="4489673"/>
             <a:chOff x="407368" y="980728"/>
-            <a:chExt cx="6840760" cy="4489673"/>
+            <a:chExt cx="9263183" cy="4489673"/>
           </a:xfrm>
         </p:grpSpPr>
-        <p:pic>
-          <p:nvPicPr>
-            <p:cNvPr id="1026" name="Picture 2">
+        <p:grpSp>
+          <p:nvGrpSpPr>
+            <p:cNvPr id="31" name="Group 30">
               <a:extLst>
                 <a:ext uri="{FF2B5EF4-FFF2-40B4-BE49-F238E27FC236}">
-                  <a16:creationId xmlns:a16="http://schemas.microsoft.com/office/drawing/2014/main" id="{E8BC94CF-CADE-151A-01CE-78CFE4424763}"/>
+                  <a16:creationId xmlns:a16="http://schemas.microsoft.com/office/drawing/2014/main" id="{20D5265E-874A-8DED-82FD-2AE029C01BB0}"/>
                 </a:ext>
               </a:extLst>
             </p:cNvPr>
-            <p:cNvPicPr>
-              <a:picLocks noChangeAspect="1" noChangeArrowheads="1"/>
-            </p:cNvPicPr>
+            <p:cNvGrpSpPr/>
             <p:nvPr/>
-          </p:nvPicPr>
-          <p:blipFill>
-            <a:blip r:embed="rId2" cstate="print">
+          </p:nvGrpSpPr>
+          <p:grpSpPr>
+            <a:xfrm>
+              <a:off x="407368" y="980728"/>
+              <a:ext cx="6840760" cy="4489673"/>
+              <a:chOff x="407368" y="980728"/>
+              <a:chExt cx="6840760" cy="4489673"/>
+            </a:xfrm>
+          </p:grpSpPr>
+          <p:pic>
+            <p:nvPicPr>
+              <p:cNvPr id="1026" name="Picture 2">
+                <a:extLst>
+                  <a:ext uri="{FF2B5EF4-FFF2-40B4-BE49-F238E27FC236}">
+                    <a16:creationId xmlns:a16="http://schemas.microsoft.com/office/drawing/2014/main" id="{E8BC94CF-CADE-151A-01CE-78CFE4424763}"/>
+                  </a:ext>
+                </a:extLst>
+              </p:cNvPr>
+              <p:cNvPicPr>
+                <a:picLocks noChangeAspect="1" noChangeArrowheads="1"/>
+              </p:cNvPicPr>
+              <p:nvPr/>
+            </p:nvPicPr>
+            <p:blipFill>
+              <a:blip r:embed="rId2" cstate="print">
+                <a:extLst>
+                  <a:ext uri="{28A0092B-C50C-407E-A947-70E740481C1C}">
+                    <a14:useLocalDpi xmlns:a14="http://schemas.microsoft.com/office/drawing/2010/main" val="0"/>
+                  </a:ext>
+                </a:extLst>
+              </a:blip>
+              <a:srcRect/>
+              <a:stretch>
+                <a:fillRect/>
+              </a:stretch>
+            </p:blipFill>
+            <p:spPr bwMode="auto">
+              <a:xfrm>
+                <a:off x="5231904" y="980728"/>
+                <a:ext cx="745257" cy="745257"/>
+              </a:xfrm>
+              <a:prstGeom prst="rect">
+                <a:avLst/>
+              </a:prstGeom>
+              <a:noFill/>
               <a:extLst>
-                <a:ext uri="{28A0092B-C50C-407E-A947-70E740481C1C}">
-                  <a14:useLocalDpi xmlns:a14="http://schemas.microsoft.com/office/drawing/2010/main" val="0"/>
+                <a:ext uri="{909E8E84-426E-40DD-AFC4-6F175D3DCCD1}">
+                  <a14:hiddenFill xmlns:a14="http://schemas.microsoft.com/office/drawing/2010/main">
+                    <a:solidFill>
+                      <a:srgbClr val="FFFFFF"/>
+                    </a:solidFill>
+                  </a14:hiddenFill>
                 </a:ext>
               </a:extLst>
-            </a:blip>
-            <a:srcRect/>
-            <a:stretch>
-              <a:fillRect/>
-            </a:stretch>
-          </p:blipFill>
-          <p:spPr bwMode="auto">
-            <a:xfrm>
-              <a:off x="5231904" y="980728"/>
-              <a:ext cx="745257" cy="745257"/>
-            </a:xfrm>
-            <a:prstGeom prst="rect">
-              <a:avLst/>
-            </a:prstGeom>
-            <a:noFill/>
-            <a:extLst>
-              <a:ext uri="{909E8E84-426E-40DD-AFC4-6F175D3DCCD1}">
-                <a14:hiddenFill xmlns:a14="http://schemas.microsoft.com/office/drawing/2010/main">
-                  <a:solidFill>
-                    <a:srgbClr val="FFFFFF"/>
-                  </a:solidFill>
-                </a14:hiddenFill>
-              </a:ext>
-            </a:extLst>
-          </p:spPr>
-        </p:pic>
+            </p:spPr>
+          </p:pic>
+          <p:sp>
+            <p:nvSpPr>
+              <p:cNvPr id="2" name="Rectangle: Rounded Corners 1">
+                <a:extLst>
+                  <a:ext uri="{FF2B5EF4-FFF2-40B4-BE49-F238E27FC236}">
+                    <a16:creationId xmlns:a16="http://schemas.microsoft.com/office/drawing/2014/main" id="{AF1F891E-F5A7-06CB-1B38-2C73AB08B3A1}"/>
+                  </a:ext>
+                </a:extLst>
+              </p:cNvPr>
+              <p:cNvSpPr/>
+              <p:nvPr/>
+            </p:nvSpPr>
+            <p:spPr>
+              <a:xfrm>
+                <a:off x="4223792" y="1772816"/>
+                <a:ext cx="3024336" cy="936104"/>
+              </a:xfrm>
+              <a:prstGeom prst="roundRect">
+                <a:avLst/>
+              </a:prstGeom>
+              <a:ln>
+                <a:noFill/>
+              </a:ln>
+            </p:spPr>
+            <p:style>
+              <a:lnRef idx="2">
+                <a:schemeClr val="accent1">
+                  <a:shade val="50000"/>
+                </a:schemeClr>
+              </a:lnRef>
+              <a:fillRef idx="1">
+                <a:schemeClr val="accent1"/>
+              </a:fillRef>
+              <a:effectRef idx="0">
+                <a:schemeClr val="accent1"/>
+              </a:effectRef>
+              <a:fontRef idx="minor">
+                <a:schemeClr val="lt1"/>
+              </a:fontRef>
+            </p:style>
+            <p:txBody>
+              <a:bodyPr rtlCol="0" anchor="ctr"/>
+              <a:lstStyle/>
+              <a:p>
+                <a:pPr algn="ctr"/>
+                <a:r>
+                  <a:rPr lang="de-DE" b="1" dirty="0">
+                    <a:latin typeface="Arial" pitchFamily="34" charset="0"/>
+                    <a:cs typeface="Arial" pitchFamily="34" charset="0"/>
+                  </a:rPr>
+                  <a:t>Liquid-to-Ambient HEX</a:t>
+                </a:r>
+                <a:endParaRPr lang="en-US" b="1" dirty="0">
+                  <a:latin typeface="Arial" pitchFamily="34" charset="0"/>
+                  <a:cs typeface="Arial" pitchFamily="34" charset="0"/>
+                </a:endParaRPr>
+              </a:p>
+            </p:txBody>
+          </p:sp>
+          <p:pic>
+            <p:nvPicPr>
+              <p:cNvPr id="1028" name="Picture 4" descr="Premium Vector | Water pump machine icon logo vector design template">
+                <a:extLst>
+                  <a:ext uri="{FF2B5EF4-FFF2-40B4-BE49-F238E27FC236}">
+                    <a16:creationId xmlns:a16="http://schemas.microsoft.com/office/drawing/2014/main" id="{D58F6404-2163-6A1F-D813-73D6F759830D}"/>
+                  </a:ext>
+                </a:extLst>
+              </p:cNvPr>
+              <p:cNvPicPr>
+                <a:picLocks noChangeAspect="1" noChangeArrowheads="1"/>
+              </p:cNvPicPr>
+              <p:nvPr/>
+            </p:nvPicPr>
+            <p:blipFill>
+              <a:blip r:embed="rId3" cstate="print">
+                <a:extLst>
+                  <a:ext uri="{28A0092B-C50C-407E-A947-70E740481C1C}">
+                    <a14:useLocalDpi xmlns:a14="http://schemas.microsoft.com/office/drawing/2010/main" val="0"/>
+                  </a:ext>
+                </a:extLst>
+              </a:blip>
+              <a:srcRect/>
+              <a:stretch>
+                <a:fillRect/>
+              </a:stretch>
+            </p:blipFill>
+            <p:spPr bwMode="auto">
+              <a:xfrm>
+                <a:off x="4799855" y="3861048"/>
+                <a:ext cx="1609353" cy="1609353"/>
+              </a:xfrm>
+              <a:prstGeom prst="rect">
+                <a:avLst/>
+              </a:prstGeom>
+              <a:noFill/>
+              <a:extLst>
+                <a:ext uri="{909E8E84-426E-40DD-AFC4-6F175D3DCCD1}">
+                  <a14:hiddenFill xmlns:a14="http://schemas.microsoft.com/office/drawing/2010/main">
+                    <a:solidFill>
+                      <a:srgbClr val="FFFFFF"/>
+                    </a:solidFill>
+                  </a14:hiddenFill>
+                </a:ext>
+              </a:extLst>
+            </p:spPr>
+          </p:pic>
+          <p:cxnSp>
+            <p:nvCxnSpPr>
+              <p:cNvPr id="7" name="Connector: Elbow 6">
+                <a:extLst>
+                  <a:ext uri="{FF2B5EF4-FFF2-40B4-BE49-F238E27FC236}">
+                    <a16:creationId xmlns:a16="http://schemas.microsoft.com/office/drawing/2014/main" id="{521A5C88-D870-AC08-6B79-BCFABFA5901A}"/>
+                  </a:ext>
+                </a:extLst>
+              </p:cNvPr>
+              <p:cNvCxnSpPr>
+                <a:cxnSpLocks/>
+                <a:stCxn id="2" idx="3"/>
+                <a:endCxn id="1028" idx="3"/>
+              </p:cNvCxnSpPr>
+              <p:nvPr/>
+            </p:nvCxnSpPr>
+            <p:spPr>
+              <a:xfrm flipH="1">
+                <a:off x="6409208" y="2240868"/>
+                <a:ext cx="838920" cy="2424857"/>
+              </a:xfrm>
+              <a:prstGeom prst="bentConnector3">
+                <a:avLst>
+                  <a:gd name="adj1" fmla="val -214923"/>
+                </a:avLst>
+              </a:prstGeom>
+              <a:ln w="76200">
+                <a:solidFill>
+                  <a:schemeClr val="accent3"/>
+                </a:solidFill>
+                <a:tailEnd type="triangle"/>
+              </a:ln>
+            </p:spPr>
+            <p:style>
+              <a:lnRef idx="1">
+                <a:schemeClr val="accent1"/>
+              </a:lnRef>
+              <a:fillRef idx="0">
+                <a:schemeClr val="accent1"/>
+              </a:fillRef>
+              <a:effectRef idx="0">
+                <a:schemeClr val="accent1"/>
+              </a:effectRef>
+              <a:fontRef idx="minor">
+                <a:schemeClr val="tx1"/>
+              </a:fontRef>
+            </p:style>
+          </p:cxnSp>
+          <p:sp>
+            <p:nvSpPr>
+              <p:cNvPr id="13" name="Rectangle: Rounded Corners 12">
+                <a:extLst>
+                  <a:ext uri="{FF2B5EF4-FFF2-40B4-BE49-F238E27FC236}">
+                    <a16:creationId xmlns:a16="http://schemas.microsoft.com/office/drawing/2014/main" id="{A409B554-1F0F-E6FC-BDAE-078E9BCD47FA}"/>
+                  </a:ext>
+                </a:extLst>
+              </p:cNvPr>
+              <p:cNvSpPr/>
+              <p:nvPr/>
+            </p:nvSpPr>
+            <p:spPr>
+              <a:xfrm>
+                <a:off x="407368" y="2996952"/>
+                <a:ext cx="1368152" cy="1008112"/>
+              </a:xfrm>
+              <a:prstGeom prst="roundRect">
+                <a:avLst/>
+              </a:prstGeom>
+              <a:solidFill>
+                <a:schemeClr val="accent5"/>
+              </a:solidFill>
+              <a:ln>
+                <a:noFill/>
+              </a:ln>
+            </p:spPr>
+            <p:style>
+              <a:lnRef idx="2">
+                <a:schemeClr val="accent1">
+                  <a:shade val="50000"/>
+                </a:schemeClr>
+              </a:lnRef>
+              <a:fillRef idx="1">
+                <a:schemeClr val="accent1"/>
+              </a:fillRef>
+              <a:effectRef idx="0">
+                <a:schemeClr val="accent1"/>
+              </a:effectRef>
+              <a:fontRef idx="minor">
+                <a:schemeClr val="lt1"/>
+              </a:fontRef>
+            </p:style>
+            <p:txBody>
+              <a:bodyPr rtlCol="0" anchor="ctr"/>
+              <a:lstStyle/>
+              <a:p>
+                <a:pPr algn="ctr"/>
+                <a:r>
+                  <a:rPr lang="de-DE" b="1" dirty="0">
+                    <a:latin typeface="Arial" pitchFamily="34" charset="0"/>
+                    <a:cs typeface="Arial" pitchFamily="34" charset="0"/>
+                  </a:rPr>
+                  <a:t>Device</a:t>
+                </a:r>
+                <a:endParaRPr lang="en-US" b="1" dirty="0">
+                  <a:latin typeface="Arial" pitchFamily="34" charset="0"/>
+                  <a:cs typeface="Arial" pitchFamily="34" charset="0"/>
+                </a:endParaRPr>
+              </a:p>
+            </p:txBody>
+          </p:sp>
+          <p:sp>
+            <p:nvSpPr>
+              <p:cNvPr id="15" name="Rectangle: Rounded Corners 14">
+                <a:extLst>
+                  <a:ext uri="{FF2B5EF4-FFF2-40B4-BE49-F238E27FC236}">
+                    <a16:creationId xmlns:a16="http://schemas.microsoft.com/office/drawing/2014/main" id="{24D5EB70-9F30-1086-CA58-5682A9828325}"/>
+                  </a:ext>
+                </a:extLst>
+              </p:cNvPr>
+              <p:cNvSpPr/>
+              <p:nvPr/>
+            </p:nvSpPr>
+            <p:spPr>
+              <a:xfrm rot="16200000">
+                <a:off x="1289466" y="3201268"/>
+                <a:ext cx="1476164" cy="504056"/>
+              </a:xfrm>
+              <a:prstGeom prst="roundRect">
+                <a:avLst/>
+              </a:prstGeom>
+              <a:ln>
+                <a:noFill/>
+              </a:ln>
+            </p:spPr>
+            <p:style>
+              <a:lnRef idx="2">
+                <a:schemeClr val="accent1">
+                  <a:shade val="50000"/>
+                </a:schemeClr>
+              </a:lnRef>
+              <a:fillRef idx="1">
+                <a:schemeClr val="accent1"/>
+              </a:fillRef>
+              <a:effectRef idx="0">
+                <a:schemeClr val="accent1"/>
+              </a:effectRef>
+              <a:fontRef idx="minor">
+                <a:schemeClr val="lt1"/>
+              </a:fontRef>
+            </p:style>
+            <p:txBody>
+              <a:bodyPr rtlCol="0" anchor="ctr"/>
+              <a:lstStyle/>
+              <a:p>
+                <a:pPr algn="ctr"/>
+                <a:r>
+                  <a:rPr lang="de-DE" b="1" dirty="0">
+                    <a:latin typeface="Arial" pitchFamily="34" charset="0"/>
+                    <a:cs typeface="Arial" pitchFamily="34" charset="0"/>
+                  </a:rPr>
+                  <a:t>Cold Plate</a:t>
+                </a:r>
+                <a:endParaRPr lang="en-US" b="1" dirty="0">
+                  <a:latin typeface="Arial" pitchFamily="34" charset="0"/>
+                  <a:cs typeface="Arial" pitchFamily="34" charset="0"/>
+                </a:endParaRPr>
+              </a:p>
+            </p:txBody>
+          </p:sp>
+          <p:cxnSp>
+            <p:nvCxnSpPr>
+              <p:cNvPr id="17" name="Connector: Elbow 16">
+                <a:extLst>
+                  <a:ext uri="{FF2B5EF4-FFF2-40B4-BE49-F238E27FC236}">
+                    <a16:creationId xmlns:a16="http://schemas.microsoft.com/office/drawing/2014/main" id="{50783807-DCF0-A2EE-890B-1E803628ECEB}"/>
+                  </a:ext>
+                </a:extLst>
+              </p:cNvPr>
+              <p:cNvCxnSpPr>
+                <a:stCxn id="1028" idx="1"/>
+                <a:endCxn id="15" idx="1"/>
+              </p:cNvCxnSpPr>
+              <p:nvPr/>
+            </p:nvCxnSpPr>
+            <p:spPr>
+              <a:xfrm rot="10800000">
+                <a:off x="2027549" y="4191379"/>
+                <a:ext cx="2772307" cy="474347"/>
+              </a:xfrm>
+              <a:prstGeom prst="bentConnector2">
+                <a:avLst/>
+              </a:prstGeom>
+              <a:ln w="76200">
+                <a:solidFill>
+                  <a:schemeClr val="accent3"/>
+                </a:solidFill>
+                <a:tailEnd type="triangle"/>
+              </a:ln>
+            </p:spPr>
+            <p:style>
+              <a:lnRef idx="1">
+                <a:schemeClr val="accent1"/>
+              </a:lnRef>
+              <a:fillRef idx="0">
+                <a:schemeClr val="accent1"/>
+              </a:fillRef>
+              <a:effectRef idx="0">
+                <a:schemeClr val="accent1"/>
+              </a:effectRef>
+              <a:fontRef idx="minor">
+                <a:schemeClr val="tx1"/>
+              </a:fontRef>
+            </p:style>
+          </p:cxnSp>
+          <p:cxnSp>
+            <p:nvCxnSpPr>
+              <p:cNvPr id="19" name="Connector: Elbow 18">
+                <a:extLst>
+                  <a:ext uri="{FF2B5EF4-FFF2-40B4-BE49-F238E27FC236}">
+                    <a16:creationId xmlns:a16="http://schemas.microsoft.com/office/drawing/2014/main" id="{403D5426-A6F7-53A9-37DD-DD196515BE9E}"/>
+                  </a:ext>
+                </a:extLst>
+              </p:cNvPr>
+              <p:cNvCxnSpPr>
+                <a:stCxn id="15" idx="3"/>
+                <a:endCxn id="2" idx="1"/>
+              </p:cNvCxnSpPr>
+              <p:nvPr/>
+            </p:nvCxnSpPr>
+            <p:spPr>
+              <a:xfrm rot="5400000" flipH="1" flipV="1">
+                <a:off x="2888497" y="1379919"/>
+                <a:ext cx="474346" cy="2196244"/>
+              </a:xfrm>
+              <a:prstGeom prst="bentConnector2">
+                <a:avLst/>
+              </a:prstGeom>
+              <a:ln w="76200">
+                <a:solidFill>
+                  <a:schemeClr val="accent5"/>
+                </a:solidFill>
+                <a:tailEnd type="triangle"/>
+              </a:ln>
+            </p:spPr>
+            <p:style>
+              <a:lnRef idx="1">
+                <a:schemeClr val="accent1"/>
+              </a:lnRef>
+              <a:fillRef idx="0">
+                <a:schemeClr val="accent1"/>
+              </a:fillRef>
+              <a:effectRef idx="0">
+                <a:schemeClr val="accent1"/>
+              </a:effectRef>
+              <a:fontRef idx="minor">
+                <a:schemeClr val="tx1"/>
+              </a:fontRef>
+            </p:style>
+          </p:cxnSp>
+        </p:grpSp>
         <p:sp>
           <p:nvSpPr>
-            <p:cNvPr id="2" name="Rectangle: Rounded Corners 1">
+            <p:cNvPr id="14" name="Rectangle 13">
               <a:extLst>
                 <a:ext uri="{FF2B5EF4-FFF2-40B4-BE49-F238E27FC236}">
-                  <a16:creationId xmlns:a16="http://schemas.microsoft.com/office/drawing/2014/main" id="{AF1F891E-F5A7-06CB-1B38-2C73AB08B3A1}"/>
+                  <a16:creationId xmlns:a16="http://schemas.microsoft.com/office/drawing/2014/main" id="{59FC3D77-4083-DA12-5F40-A4472BAD9516}"/>
                 </a:ext>
               </a:extLst>
             </p:cNvPr>
@@ -3519,168 +3905,14 @@
           </p:nvSpPr>
           <p:spPr>
             <a:xfrm>
-              <a:off x="4223792" y="1772816"/>
-              <a:ext cx="3024336" cy="936104"/>
-            </a:xfrm>
-            <a:prstGeom prst="roundRect">
-              <a:avLst/>
-            </a:prstGeom>
-            <a:ln>
-              <a:noFill/>
-            </a:ln>
-          </p:spPr>
-          <p:style>
-            <a:lnRef idx="2">
-              <a:schemeClr val="accent1">
-                <a:shade val="50000"/>
-              </a:schemeClr>
-            </a:lnRef>
-            <a:fillRef idx="1">
-              <a:schemeClr val="accent1"/>
-            </a:fillRef>
-            <a:effectRef idx="0">
-              <a:schemeClr val="accent1"/>
-            </a:effectRef>
-            <a:fontRef idx="minor">
-              <a:schemeClr val="lt1"/>
-            </a:fontRef>
-          </p:style>
-          <p:txBody>
-            <a:bodyPr rtlCol="0" anchor="ctr"/>
-            <a:lstStyle/>
-            <a:p>
-              <a:pPr algn="ctr"/>
-              <a:r>
-                <a:rPr lang="de-DE" b="1" dirty="0">
-                  <a:latin typeface="Arial" pitchFamily="34" charset="0"/>
-                  <a:cs typeface="Arial" pitchFamily="34" charset="0"/>
-                </a:rPr>
-                <a:t>Liquid-to-Ambient HEX</a:t>
-              </a:r>
-              <a:endParaRPr lang="en-US" b="1" dirty="0">
-                <a:latin typeface="Arial" pitchFamily="34" charset="0"/>
-                <a:cs typeface="Arial" pitchFamily="34" charset="0"/>
-              </a:endParaRPr>
-            </a:p>
-          </p:txBody>
-        </p:sp>
-        <p:pic>
-          <p:nvPicPr>
-            <p:cNvPr id="1028" name="Picture 4" descr="Premium Vector | Water pump machine icon logo vector design template">
-              <a:extLst>
-                <a:ext uri="{FF2B5EF4-FFF2-40B4-BE49-F238E27FC236}">
-                  <a16:creationId xmlns:a16="http://schemas.microsoft.com/office/drawing/2014/main" id="{D58F6404-2163-6A1F-D813-73D6F759830D}"/>
-                </a:ext>
-              </a:extLst>
-            </p:cNvPr>
-            <p:cNvPicPr>
-              <a:picLocks noChangeAspect="1" noChangeArrowheads="1"/>
-            </p:cNvPicPr>
-            <p:nvPr/>
-          </p:nvPicPr>
-          <p:blipFill>
-            <a:blip r:embed="rId3" cstate="print">
-              <a:extLst>
-                <a:ext uri="{28A0092B-C50C-407E-A947-70E740481C1C}">
-                  <a14:useLocalDpi xmlns:a14="http://schemas.microsoft.com/office/drawing/2010/main" val="0"/>
-                </a:ext>
-              </a:extLst>
-            </a:blip>
-            <a:srcRect/>
-            <a:stretch>
-              <a:fillRect/>
-            </a:stretch>
-          </p:blipFill>
-          <p:spPr bwMode="auto">
-            <a:xfrm>
-              <a:off x="4799855" y="3861048"/>
-              <a:ext cx="1609353" cy="1609353"/>
+              <a:off x="4295800" y="3378142"/>
+              <a:ext cx="644400" cy="360040"/>
             </a:xfrm>
             <a:prstGeom prst="rect">
               <a:avLst/>
             </a:prstGeom>
-            <a:noFill/>
-            <a:extLst>
-              <a:ext uri="{909E8E84-426E-40DD-AFC4-6F175D3DCCD1}">
-                <a14:hiddenFill xmlns:a14="http://schemas.microsoft.com/office/drawing/2010/main">
-                  <a:solidFill>
-                    <a:srgbClr val="FFFFFF"/>
-                  </a:solidFill>
-                </a14:hiddenFill>
-              </a:ext>
-            </a:extLst>
-          </p:spPr>
-        </p:pic>
-        <p:cxnSp>
-          <p:nvCxnSpPr>
-            <p:cNvPr id="7" name="Connector: Elbow 6">
-              <a:extLst>
-                <a:ext uri="{FF2B5EF4-FFF2-40B4-BE49-F238E27FC236}">
-                  <a16:creationId xmlns:a16="http://schemas.microsoft.com/office/drawing/2014/main" id="{521A5C88-D870-AC08-6B79-BCFABFA5901A}"/>
-                </a:ext>
-              </a:extLst>
-            </p:cNvPr>
-            <p:cNvCxnSpPr>
-              <a:cxnSpLocks/>
-              <a:stCxn id="2" idx="3"/>
-              <a:endCxn id="1028" idx="3"/>
-            </p:cNvCxnSpPr>
-            <p:nvPr/>
-          </p:nvCxnSpPr>
-          <p:spPr>
-            <a:xfrm flipH="1">
-              <a:off x="6409208" y="2240868"/>
-              <a:ext cx="838920" cy="2424857"/>
-            </a:xfrm>
-            <a:prstGeom prst="bentConnector3">
-              <a:avLst>
-                <a:gd name="adj1" fmla="val -192238"/>
-              </a:avLst>
-            </a:prstGeom>
-            <a:ln w="76200">
-              <a:solidFill>
-                <a:schemeClr val="accent3"/>
-              </a:solidFill>
-              <a:tailEnd type="triangle"/>
-            </a:ln>
-          </p:spPr>
-          <p:style>
-            <a:lnRef idx="1">
-              <a:schemeClr val="accent1"/>
-            </a:lnRef>
-            <a:fillRef idx="0">
-              <a:schemeClr val="accent1"/>
-            </a:fillRef>
-            <a:effectRef idx="0">
-              <a:schemeClr val="accent1"/>
-            </a:effectRef>
-            <a:fontRef idx="minor">
-              <a:schemeClr val="tx1"/>
-            </a:fontRef>
-          </p:style>
-        </p:cxnSp>
-        <p:sp>
-          <p:nvSpPr>
-            <p:cNvPr id="13" name="Rectangle: Rounded Corners 12">
-              <a:extLst>
-                <a:ext uri="{FF2B5EF4-FFF2-40B4-BE49-F238E27FC236}">
-                  <a16:creationId xmlns:a16="http://schemas.microsoft.com/office/drawing/2014/main" id="{A409B554-1F0F-E6FC-BDAE-078E9BCD47FA}"/>
-                </a:ext>
-              </a:extLst>
-            </p:cNvPr>
-            <p:cNvSpPr/>
-            <p:nvPr/>
-          </p:nvSpPr>
-          <p:spPr>
-            <a:xfrm>
-              <a:off x="407368" y="2996952"/>
-              <a:ext cx="1368152" cy="1008112"/>
-            </a:xfrm>
-            <a:prstGeom prst="roundRect">
-              <a:avLst/>
-            </a:prstGeom>
             <a:solidFill>
-              <a:schemeClr val="accent5"/>
+              <a:schemeClr val="bg1"/>
             </a:solidFill>
             <a:ln>
               <a:noFill/>
@@ -3707,12 +3939,308 @@
             <a:lstStyle/>
             <a:p>
               <a:pPr algn="ctr"/>
+              <a:endParaRPr lang="en-US" b="1" dirty="0">
+                <a:latin typeface="Arial" pitchFamily="34" charset="0"/>
+                <a:cs typeface="Arial" pitchFamily="34" charset="0"/>
+              </a:endParaRPr>
+            </a:p>
+          </p:txBody>
+        </p:sp>
+        <p:grpSp>
+          <p:nvGrpSpPr>
+            <p:cNvPr id="35" name="Group 34">
+              <a:extLst>
+                <a:ext uri="{FF2B5EF4-FFF2-40B4-BE49-F238E27FC236}">
+                  <a16:creationId xmlns:a16="http://schemas.microsoft.com/office/drawing/2014/main" id="{672B7E98-A1C8-C6F5-E4D5-F916463508A7}"/>
+                </a:ext>
+              </a:extLst>
+            </p:cNvPr>
+            <p:cNvGrpSpPr/>
+            <p:nvPr/>
+          </p:nvGrpSpPr>
+          <p:grpSpPr>
+            <a:xfrm>
+              <a:off x="7125616" y="3389486"/>
+              <a:ext cx="864096" cy="1224136"/>
+              <a:chOff x="7125616" y="3389486"/>
+              <a:chExt cx="864096" cy="1224136"/>
+            </a:xfrm>
+          </p:grpSpPr>
+          <p:cxnSp>
+            <p:nvCxnSpPr>
+              <p:cNvPr id="4" name="Straight Connector 3">
+                <a:extLst>
+                  <a:ext uri="{FF2B5EF4-FFF2-40B4-BE49-F238E27FC236}">
+                    <a16:creationId xmlns:a16="http://schemas.microsoft.com/office/drawing/2014/main" id="{D24539DB-ED86-C94D-CDF8-B2FA3E0A63A2}"/>
+                  </a:ext>
+                </a:extLst>
+              </p:cNvPr>
+              <p:cNvCxnSpPr/>
+              <p:nvPr/>
+            </p:nvCxnSpPr>
+            <p:spPr>
+              <a:xfrm flipV="1">
+                <a:off x="7557664" y="4397598"/>
+                <a:ext cx="0" cy="216024"/>
+              </a:xfrm>
+              <a:prstGeom prst="line">
+                <a:avLst/>
+              </a:prstGeom>
+              <a:ln w="76200">
+                <a:tailEnd type="none"/>
+              </a:ln>
+            </p:spPr>
+            <p:style>
+              <a:lnRef idx="1">
+                <a:schemeClr val="dk1"/>
+              </a:lnRef>
+              <a:fillRef idx="0">
+                <a:schemeClr val="dk1"/>
+              </a:fillRef>
+              <a:effectRef idx="0">
+                <a:schemeClr val="dk1"/>
+              </a:effectRef>
+              <a:fontRef idx="minor">
+                <a:schemeClr val="tx1"/>
+              </a:fontRef>
+            </p:style>
+          </p:cxnSp>
+          <p:sp>
+            <p:nvSpPr>
+              <p:cNvPr id="18" name="Rectangle: Rounded Corners 17">
+                <a:extLst>
+                  <a:ext uri="{FF2B5EF4-FFF2-40B4-BE49-F238E27FC236}">
+                    <a16:creationId xmlns:a16="http://schemas.microsoft.com/office/drawing/2014/main" id="{C132F2C0-ED4D-16B9-7080-4CDC307CC5B1}"/>
+                  </a:ext>
+                </a:extLst>
+              </p:cNvPr>
+              <p:cNvSpPr/>
+              <p:nvPr/>
+            </p:nvSpPr>
+            <p:spPr>
+              <a:xfrm>
+                <a:off x="7125616" y="3389486"/>
+                <a:ext cx="864096" cy="1008112"/>
+              </a:xfrm>
+              <a:prstGeom prst="roundRect">
+                <a:avLst>
+                  <a:gd name="adj" fmla="val 37243"/>
+                </a:avLst>
+              </a:prstGeom>
+              <a:noFill/>
+              <a:ln w="76200">
+                <a:solidFill>
+                  <a:schemeClr val="tx1"/>
+                </a:solidFill>
+              </a:ln>
+            </p:spPr>
+            <p:style>
+              <a:lnRef idx="2">
+                <a:schemeClr val="accent1">
+                  <a:shade val="50000"/>
+                </a:schemeClr>
+              </a:lnRef>
+              <a:fillRef idx="1">
+                <a:schemeClr val="accent1"/>
+              </a:fillRef>
+              <a:effectRef idx="0">
+                <a:schemeClr val="accent1"/>
+              </a:effectRef>
+              <a:fontRef idx="minor">
+                <a:schemeClr val="lt1"/>
+              </a:fontRef>
+            </p:style>
+            <p:txBody>
+              <a:bodyPr rtlCol="0" anchor="ctr"/>
+              <a:lstStyle/>
+              <a:p>
+                <a:pPr algn="ctr"/>
+                <a:endParaRPr lang="en-US" b="1" dirty="0">
+                  <a:latin typeface="Arial" pitchFamily="34" charset="0"/>
+                  <a:cs typeface="Arial" pitchFamily="34" charset="0"/>
+                </a:endParaRPr>
+              </a:p>
+            </p:txBody>
+          </p:sp>
+          <p:cxnSp>
+            <p:nvCxnSpPr>
+              <p:cNvPr id="21" name="Straight Connector 20">
+                <a:extLst>
+                  <a:ext uri="{FF2B5EF4-FFF2-40B4-BE49-F238E27FC236}">
+                    <a16:creationId xmlns:a16="http://schemas.microsoft.com/office/drawing/2014/main" id="{9B241A2A-ED89-DBD7-8E43-6478C3363AB8}"/>
+                  </a:ext>
+                </a:extLst>
+              </p:cNvPr>
+              <p:cNvCxnSpPr>
+                <a:cxnSpLocks/>
+              </p:cNvCxnSpPr>
+              <p:nvPr/>
+            </p:nvCxnSpPr>
+            <p:spPr>
+              <a:xfrm>
+                <a:off x="7125616" y="3893542"/>
+                <a:ext cx="338536" cy="0"/>
+              </a:xfrm>
+              <a:prstGeom prst="line">
+                <a:avLst/>
+              </a:prstGeom>
+              <a:noFill/>
+              <a:ln w="76200">
+                <a:solidFill>
+                  <a:schemeClr val="tx1"/>
+                </a:solidFill>
+              </a:ln>
+            </p:spPr>
+            <p:style>
+              <a:lnRef idx="2">
+                <a:schemeClr val="accent1">
+                  <a:shade val="50000"/>
+                </a:schemeClr>
+              </a:lnRef>
+              <a:fillRef idx="1">
+                <a:schemeClr val="accent1"/>
+              </a:fillRef>
+              <a:effectRef idx="0">
+                <a:schemeClr val="accent1"/>
+              </a:effectRef>
+              <a:fontRef idx="minor">
+                <a:schemeClr val="lt1"/>
+              </a:fontRef>
+            </p:style>
+          </p:cxnSp>
+          <p:cxnSp>
+            <p:nvCxnSpPr>
+              <p:cNvPr id="23" name="Straight Connector 22">
+                <a:extLst>
+                  <a:ext uri="{FF2B5EF4-FFF2-40B4-BE49-F238E27FC236}">
+                    <a16:creationId xmlns:a16="http://schemas.microsoft.com/office/drawing/2014/main" id="{7C6FE5CD-33E0-530D-98CF-02610A63EDE7}"/>
+                  </a:ext>
+                </a:extLst>
+              </p:cNvPr>
+              <p:cNvCxnSpPr>
+                <a:cxnSpLocks/>
+              </p:cNvCxnSpPr>
+              <p:nvPr/>
+            </p:nvCxnSpPr>
+            <p:spPr>
+              <a:xfrm>
+                <a:off x="7680176" y="3895130"/>
+                <a:ext cx="309536" cy="0"/>
+              </a:xfrm>
+              <a:prstGeom prst="line">
+                <a:avLst/>
+              </a:prstGeom>
+              <a:noFill/>
+              <a:ln w="76200">
+                <a:solidFill>
+                  <a:schemeClr val="tx1"/>
+                </a:solidFill>
+              </a:ln>
+            </p:spPr>
+            <p:style>
+              <a:lnRef idx="2">
+                <a:schemeClr val="accent1">
+                  <a:shade val="50000"/>
+                </a:schemeClr>
+              </a:lnRef>
+              <a:fillRef idx="1">
+                <a:schemeClr val="accent1"/>
+              </a:fillRef>
+              <a:effectRef idx="0">
+                <a:schemeClr val="accent1"/>
+              </a:effectRef>
+              <a:fontRef idx="minor">
+                <a:schemeClr val="lt1"/>
+              </a:fontRef>
+            </p:style>
+          </p:cxnSp>
+          <p:sp>
+            <p:nvSpPr>
+              <p:cNvPr id="34" name="Arc 33">
+                <a:extLst>
+                  <a:ext uri="{FF2B5EF4-FFF2-40B4-BE49-F238E27FC236}">
+                    <a16:creationId xmlns:a16="http://schemas.microsoft.com/office/drawing/2014/main" id="{C6050AA8-9A3C-E4E9-F1C0-F2C838AEE6E1}"/>
+                  </a:ext>
+                </a:extLst>
+              </p:cNvPr>
+              <p:cNvSpPr/>
+              <p:nvPr/>
+            </p:nvSpPr>
+            <p:spPr>
+              <a:xfrm>
+                <a:off x="7436835" y="3790099"/>
+                <a:ext cx="270659" cy="288030"/>
+              </a:xfrm>
+              <a:prstGeom prst="arc">
+                <a:avLst>
+                  <a:gd name="adj1" fmla="val 10899181"/>
+                  <a:gd name="adj2" fmla="val 0"/>
+                </a:avLst>
+              </a:prstGeom>
+              <a:ln w="76200">
+                <a:solidFill>
+                  <a:schemeClr val="tx1"/>
+                </a:solidFill>
+              </a:ln>
+            </p:spPr>
+            <p:style>
+              <a:lnRef idx="1">
+                <a:schemeClr val="accent1"/>
+              </a:lnRef>
+              <a:fillRef idx="0">
+                <a:schemeClr val="accent1"/>
+              </a:fillRef>
+              <a:effectRef idx="0">
+                <a:schemeClr val="accent1"/>
+              </a:effectRef>
+              <a:fontRef idx="minor">
+                <a:schemeClr val="tx1"/>
+              </a:fontRef>
+            </p:style>
+            <p:txBody>
+              <a:bodyPr rtlCol="0" anchor="ctr"/>
+              <a:lstStyle/>
+              <a:p>
+                <a:pPr algn="ctr"/>
+                <a:endParaRPr lang="en-US"/>
+              </a:p>
+            </p:txBody>
+          </p:sp>
+        </p:grpSp>
+        <p:sp>
+          <p:nvSpPr>
+            <p:cNvPr id="36" name="TextBox 35">
+              <a:extLst>
+                <a:ext uri="{FF2B5EF4-FFF2-40B4-BE49-F238E27FC236}">
+                  <a16:creationId xmlns:a16="http://schemas.microsoft.com/office/drawing/2014/main" id="{A4746E7D-5F44-9862-59C2-9D05F2658888}"/>
+                </a:ext>
+              </a:extLst>
+            </p:cNvPr>
+            <p:cNvSpPr txBox="1"/>
+            <p:nvPr/>
+          </p:nvSpPr>
+          <p:spPr>
+            <a:xfrm>
+              <a:off x="5303912" y="5065997"/>
+              <a:ext cx="864096" cy="369332"/>
+            </a:xfrm>
+            <a:prstGeom prst="rect">
+              <a:avLst/>
+            </a:prstGeom>
+            <a:noFill/>
+          </p:spPr>
+          <p:txBody>
+            <a:bodyPr wrap="square" rtlCol="0">
+              <a:spAutoFit/>
+            </a:bodyPr>
+            <a:lstStyle/>
+            <a:p>
               <a:r>
                 <a:rPr lang="de-DE" b="1" dirty="0">
                   <a:latin typeface="Arial" pitchFamily="34" charset="0"/>
                   <a:cs typeface="Arial" pitchFamily="34" charset="0"/>
                 </a:rPr>
-                <a:t>Device</a:t>
+                <a:t>Pump</a:t>
               </a:r>
               <a:endParaRPr lang="en-US" b="1" dirty="0">
                 <a:latin typeface="Arial" pitchFamily="34" charset="0"/>
@@ -3723,55 +4251,38 @@
         </p:sp>
         <p:sp>
           <p:nvSpPr>
-            <p:cNvPr id="15" name="Rectangle: Rounded Corners 14">
+            <p:cNvPr id="37" name="TextBox 36">
               <a:extLst>
                 <a:ext uri="{FF2B5EF4-FFF2-40B4-BE49-F238E27FC236}">
-                  <a16:creationId xmlns:a16="http://schemas.microsoft.com/office/drawing/2014/main" id="{24D5EB70-9F30-1086-CA58-5682A9828325}"/>
+                  <a16:creationId xmlns:a16="http://schemas.microsoft.com/office/drawing/2014/main" id="{9F40AB24-98C0-5876-A217-1878793CCF1A}"/>
                 </a:ext>
               </a:extLst>
             </p:cNvPr>
-            <p:cNvSpPr/>
+            <p:cNvSpPr txBox="1"/>
             <p:nvPr/>
           </p:nvSpPr>
           <p:spPr>
-            <a:xfrm rot="16200000">
-              <a:off x="1289466" y="3201268"/>
-              <a:ext cx="1476164" cy="504056"/>
+            <a:xfrm>
+              <a:off x="7603823" y="2768087"/>
+              <a:ext cx="2066728" cy="646331"/>
             </a:xfrm>
-            <a:prstGeom prst="roundRect">
+            <a:prstGeom prst="rect">
               <a:avLst/>
             </a:prstGeom>
-            <a:ln>
-              <a:noFill/>
-            </a:ln>
+            <a:noFill/>
           </p:spPr>
-          <p:style>
-            <a:lnRef idx="2">
-              <a:schemeClr val="accent1">
-                <a:shade val="50000"/>
-              </a:schemeClr>
-            </a:lnRef>
-            <a:fillRef idx="1">
-              <a:schemeClr val="accent1"/>
-            </a:fillRef>
-            <a:effectRef idx="0">
-              <a:schemeClr val="accent1"/>
-            </a:effectRef>
-            <a:fontRef idx="minor">
-              <a:schemeClr val="lt1"/>
-            </a:fontRef>
-          </p:style>
           <p:txBody>
-            <a:bodyPr rtlCol="0" anchor="ctr"/>
+            <a:bodyPr wrap="square" rtlCol="0">
+              <a:spAutoFit/>
+            </a:bodyPr>
             <a:lstStyle/>
             <a:p>
-              <a:pPr algn="ctr"/>
               <a:r>
                 <a:rPr lang="de-DE" b="1" dirty="0">
                   <a:latin typeface="Arial" pitchFamily="34" charset="0"/>
                   <a:cs typeface="Arial" pitchFamily="34" charset="0"/>
                 </a:rPr>
-                <a:t>Cold Plate</a:t>
+                <a:t>Expansion Device</a:t>
               </a:r>
               <a:endParaRPr lang="en-US" b="1" dirty="0">
                 <a:latin typeface="Arial" pitchFamily="34" charset="0"/>
@@ -3780,96 +4291,6 @@
             </a:p>
           </p:txBody>
         </p:sp>
-        <p:cxnSp>
-          <p:nvCxnSpPr>
-            <p:cNvPr id="17" name="Connector: Elbow 16">
-              <a:extLst>
-                <a:ext uri="{FF2B5EF4-FFF2-40B4-BE49-F238E27FC236}">
-                  <a16:creationId xmlns:a16="http://schemas.microsoft.com/office/drawing/2014/main" id="{50783807-DCF0-A2EE-890B-1E803628ECEB}"/>
-                </a:ext>
-              </a:extLst>
-            </p:cNvPr>
-            <p:cNvCxnSpPr>
-              <a:stCxn id="1028" idx="1"/>
-              <a:endCxn id="15" idx="1"/>
-            </p:cNvCxnSpPr>
-            <p:nvPr/>
-          </p:nvCxnSpPr>
-          <p:spPr>
-            <a:xfrm rot="10800000">
-              <a:off x="2027549" y="4191379"/>
-              <a:ext cx="2772307" cy="474347"/>
-            </a:xfrm>
-            <a:prstGeom prst="bentConnector2">
-              <a:avLst/>
-            </a:prstGeom>
-            <a:ln w="76200">
-              <a:solidFill>
-                <a:schemeClr val="accent3"/>
-              </a:solidFill>
-              <a:tailEnd type="triangle"/>
-            </a:ln>
-          </p:spPr>
-          <p:style>
-            <a:lnRef idx="1">
-              <a:schemeClr val="accent1"/>
-            </a:lnRef>
-            <a:fillRef idx="0">
-              <a:schemeClr val="accent1"/>
-            </a:fillRef>
-            <a:effectRef idx="0">
-              <a:schemeClr val="accent1"/>
-            </a:effectRef>
-            <a:fontRef idx="minor">
-              <a:schemeClr val="tx1"/>
-            </a:fontRef>
-          </p:style>
-        </p:cxnSp>
-        <p:cxnSp>
-          <p:nvCxnSpPr>
-            <p:cNvPr id="19" name="Connector: Elbow 18">
-              <a:extLst>
-                <a:ext uri="{FF2B5EF4-FFF2-40B4-BE49-F238E27FC236}">
-                  <a16:creationId xmlns:a16="http://schemas.microsoft.com/office/drawing/2014/main" id="{403D5426-A6F7-53A9-37DD-DD196515BE9E}"/>
-                </a:ext>
-              </a:extLst>
-            </p:cNvPr>
-            <p:cNvCxnSpPr>
-              <a:stCxn id="15" idx="3"/>
-              <a:endCxn id="2" idx="1"/>
-            </p:cNvCxnSpPr>
-            <p:nvPr/>
-          </p:nvCxnSpPr>
-          <p:spPr>
-            <a:xfrm rot="5400000" flipH="1" flipV="1">
-              <a:off x="2888497" y="1379919"/>
-              <a:ext cx="474346" cy="2196244"/>
-            </a:xfrm>
-            <a:prstGeom prst="bentConnector2">
-              <a:avLst/>
-            </a:prstGeom>
-            <a:ln w="76200">
-              <a:solidFill>
-                <a:schemeClr val="accent5"/>
-              </a:solidFill>
-              <a:tailEnd type="triangle"/>
-            </a:ln>
-          </p:spPr>
-          <p:style>
-            <a:lnRef idx="1">
-              <a:schemeClr val="accent1"/>
-            </a:lnRef>
-            <a:fillRef idx="0">
-              <a:schemeClr val="accent1"/>
-            </a:fillRef>
-            <a:effectRef idx="0">
-              <a:schemeClr val="accent1"/>
-            </a:effectRef>
-            <a:fontRef idx="minor">
-              <a:schemeClr val="tx1"/>
-            </a:fontRef>
-          </p:style>
-        </p:cxnSp>
       </p:grpSp>
     </p:spTree>
     <p:extLst>
@@ -13476,10 +13897,10 @@
       </p:grpSpPr>
       <p:pic>
         <p:nvPicPr>
-          <p:cNvPr id="41" name="Picture 40">
+          <p:cNvPr id="21" name="Picture 20">
             <a:extLst>
               <a:ext uri="{FF2B5EF4-FFF2-40B4-BE49-F238E27FC236}">
-                <a16:creationId xmlns:a16="http://schemas.microsoft.com/office/drawing/2014/main" id="{9B2462A1-B4A3-24F4-925B-AEECC3530C7A}"/>
+                <a16:creationId xmlns:a16="http://schemas.microsoft.com/office/drawing/2014/main" id="{1CE01EAF-D7EB-74F4-86AE-347ABCCD49D8}"/>
               </a:ext>
             </a:extLst>
           </p:cNvPr>
@@ -13496,8 +13917,8 @@
         </p:blipFill>
         <p:spPr>
           <a:xfrm>
-            <a:off x="1846719" y="1185477"/>
-            <a:ext cx="8498561" cy="4487045"/>
+            <a:off x="1465686" y="1154995"/>
+            <a:ext cx="9260627" cy="4548010"/>
           </a:xfrm>
           <a:prstGeom prst="rect">
             <a:avLst/>
@@ -24768,21 +25189,6 @@
 </file>
 
 <file path=customXml/item1.xml><?xml version="1.0" encoding="utf-8"?>
-<p:properties xmlns:p="http://schemas.microsoft.com/office/2006/metadata/properties" xmlns:xsi="http://www.w3.org/2001/XMLSchema-instance" xmlns:pc="http://schemas.microsoft.com/office/infopath/2007/PartnerControls">
-  <documentManagement/>
-</p:properties>
-</file>
-
-<file path=customXml/item2.xml><?xml version="1.0" encoding="utf-8"?>
-<?mso-contentType ?>
-<FormTemplates xmlns="http://schemas.microsoft.com/sharepoint/v3/contenttype/forms">
-  <Display>DocumentLibraryForm</Display>
-  <Edit>DocumentLibraryForm</Edit>
-  <New>DocumentLibraryForm</New>
-</FormTemplates>
-</file>
-
-<file path=customXml/item3.xml><?xml version="1.0" encoding="utf-8"?>
 <ct:contentTypeSchema xmlns:ct="http://schemas.microsoft.com/office/2006/metadata/contentType" xmlns:ma="http://schemas.microsoft.com/office/2006/metadata/properties/metaAttributes" ct:_="" ma:_="" ma:contentTypeName="Document" ma:contentTypeID="0x010100E8BDF109259C3742B70118398EA662DF" ma:contentTypeVersion="4" ma:contentTypeDescription="Create a new document." ma:contentTypeScope="" ma:versionID="739f9c85490d5e8d428cdd675dd8c7cd">
   <xsd:schema xmlns:xsd="http://www.w3.org/2001/XMLSchema" xmlns:xs="http://www.w3.org/2001/XMLSchema" xmlns:p="http://schemas.microsoft.com/office/2006/metadata/properties" xmlns:ns2="c0427815-c159-405c-a9c3-9204bd95a48e" targetNamespace="http://schemas.microsoft.com/office/2006/metadata/properties" ma:root="true" ma:fieldsID="3e30fb21375f54844de811bb38b6912f" ns2:_="">
     <xsd:import namespace="c0427815-c159-405c-a9c3-9204bd95a48e"/>
@@ -24926,7 +25332,48 @@
 </ct:contentTypeSchema>
 </file>
 
+<file path=customXml/item2.xml><?xml version="1.0" encoding="utf-8"?>
+<?mso-contentType ?>
+<FormTemplates xmlns="http://schemas.microsoft.com/sharepoint/v3/contenttype/forms">
+  <Display>DocumentLibraryForm</Display>
+  <Edit>DocumentLibraryForm</Edit>
+  <New>DocumentLibraryForm</New>
+</FormTemplates>
+</file>
+
+<file path=customXml/item3.xml><?xml version="1.0" encoding="utf-8"?>
+<p:properties xmlns:p="http://schemas.microsoft.com/office/2006/metadata/properties" xmlns:xsi="http://www.w3.org/2001/XMLSchema-instance" xmlns:pc="http://schemas.microsoft.com/office/infopath/2007/PartnerControls">
+  <documentManagement/>
+</p:properties>
+</file>
+
 <file path=customXml/itemProps1.xml><?xml version="1.0" encoding="utf-8"?>
+<ds:datastoreItem xmlns:ds="http://schemas.openxmlformats.org/officeDocument/2006/customXml" ds:itemID="{183B886A-FCC7-4CFA-98AF-7EF1C1F11BA2}">
+  <ds:schemaRefs>
+    <ds:schemaRef ds:uri="http://schemas.microsoft.com/office/2006/metadata/contentType"/>
+    <ds:schemaRef ds:uri="http://schemas.microsoft.com/office/2006/metadata/properties/metaAttributes"/>
+    <ds:schemaRef ds:uri="http://www.w3.org/2001/XMLSchema"/>
+    <ds:schemaRef ds:uri="http://schemas.microsoft.com/office/2006/metadata/properties"/>
+    <ds:schemaRef ds:uri="c0427815-c159-405c-a9c3-9204bd95a48e"/>
+    <ds:schemaRef ds:uri="http://schemas.microsoft.com/office/2006/documentManagement/types"/>
+    <ds:schemaRef ds:uri="http://schemas.microsoft.com/office/infopath/2007/PartnerControls"/>
+    <ds:schemaRef ds:uri="http://schemas.openxmlformats.org/package/2006/metadata/core-properties"/>
+    <ds:schemaRef ds:uri="http://purl.org/dc/elements/1.1/"/>
+    <ds:schemaRef ds:uri="http://purl.org/dc/terms/"/>
+    <ds:schemaRef ds:uri="http://schemas.microsoft.com/internal/obd"/>
+  </ds:schemaRefs>
+</ds:datastoreItem>
+</file>
+
+<file path=customXml/itemProps2.xml><?xml version="1.0" encoding="utf-8"?>
+<ds:datastoreItem xmlns:ds="http://schemas.openxmlformats.org/officeDocument/2006/customXml" ds:itemID="{3B61DF2E-245C-45DF-A9A5-EABECEA4295F}">
+  <ds:schemaRefs>
+    <ds:schemaRef ds:uri="http://schemas.microsoft.com/sharepoint/v3/contenttype/forms"/>
+  </ds:schemaRefs>
+</ds:datastoreItem>
+</file>
+
+<file path=customXml/itemProps3.xml><?xml version="1.0" encoding="utf-8"?>
 <ds:datastoreItem xmlns:ds="http://schemas.openxmlformats.org/officeDocument/2006/customXml" ds:itemID="{73B851B7-D313-4E85-A1E0-5976CFE11EC3}">
   <ds:schemaRefs>
     <ds:schemaRef ds:uri="http://schemas.openxmlformats.org/package/2006/metadata/core-properties"/>
@@ -24942,30 +25389,4 @@
     <ds:schemaRef ds:uri="a70944c9-f5be-4b0f-89c7-00caf47c665c"/>
   </ds:schemaRefs>
 </ds:datastoreItem>
-</file>
-
-<file path=customXml/itemProps2.xml><?xml version="1.0" encoding="utf-8"?>
-<ds:datastoreItem xmlns:ds="http://schemas.openxmlformats.org/officeDocument/2006/customXml" ds:itemID="{3B61DF2E-245C-45DF-A9A5-EABECEA4295F}">
-  <ds:schemaRefs>
-    <ds:schemaRef ds:uri="http://schemas.microsoft.com/sharepoint/v3/contenttype/forms"/>
-  </ds:schemaRefs>
-</ds:datastoreItem>
-</file>
-
-<file path=customXml/itemProps3.xml><?xml version="1.0" encoding="utf-8"?>
-<ds:datastoreItem xmlns:ds="http://schemas.openxmlformats.org/officeDocument/2006/customXml" ds:itemID="{183B886A-FCC7-4CFA-98AF-7EF1C1F11BA2}">
-  <ds:schemaRefs>
-    <ds:schemaRef ds:uri="http://schemas.microsoft.com/office/2006/metadata/contentType"/>
-    <ds:schemaRef ds:uri="http://schemas.microsoft.com/office/2006/metadata/properties/metaAttributes"/>
-    <ds:schemaRef ds:uri="http://www.w3.org/2001/XMLSchema"/>
-    <ds:schemaRef ds:uri="http://schemas.microsoft.com/office/2006/metadata/properties"/>
-    <ds:schemaRef ds:uri="c0427815-c159-405c-a9c3-9204bd95a48e"/>
-    <ds:schemaRef ds:uri="http://schemas.microsoft.com/office/2006/documentManagement/types"/>
-    <ds:schemaRef ds:uri="http://schemas.microsoft.com/office/infopath/2007/PartnerControls"/>
-    <ds:schemaRef ds:uri="http://schemas.openxmlformats.org/package/2006/metadata/core-properties"/>
-    <ds:schemaRef ds:uri="http://purl.org/dc/elements/1.1/"/>
-    <ds:schemaRef ds:uri="http://purl.org/dc/terms/"/>
-    <ds:schemaRef ds:uri="http://schemas.microsoft.com/internal/obd"/>
-  </ds:schemaRefs>
-</ds:datastoreItem>
 </file>
</xml_diff>